<commit_message>
update repherat and menu
</commit_message>
<xml_diff>
--- a/presentation.pptx
+++ b/presentation.pptx
@@ -212,7 +212,7 @@
           <a:p>
             <a:fld id="{9CF9DDCD-6582-4FC2-87A2-FA2F2F89B44A}" type="datetimeFigureOut">
               <a:rPr lang="ru-RU" smtClean="0"/>
-              <a:t>22.04.2026</a:t>
+              <a:t>29.04.2026</a:t>
             </a:fld>
             <a:endParaRPr lang="ru-RU"/>
           </a:p>
@@ -710,7 +710,7 @@
           <a:p>
             <a:fld id="{E2D3E6BD-B4C5-4C5E-AC73-5E733A3CDA2C}" type="datetime1">
               <a:rPr lang="ru-RU" smtClean="0"/>
-              <a:t>22.04.2026</a:t>
+              <a:t>29.04.2026</a:t>
             </a:fld>
             <a:endParaRPr lang="ru-RU"/>
           </a:p>
@@ -908,7 +908,7 @@
           <a:p>
             <a:fld id="{D7D4D24D-E8DE-46D2-B2EA-B77A9C5FF877}" type="datetime1">
               <a:rPr lang="ru-RU" smtClean="0"/>
-              <a:t>22.04.2026</a:t>
+              <a:t>29.04.2026</a:t>
             </a:fld>
             <a:endParaRPr lang="ru-RU"/>
           </a:p>
@@ -1116,7 +1116,7 @@
           <a:p>
             <a:fld id="{67B76F11-00B9-4E07-B295-6CA67D2F7E8B}" type="datetime1">
               <a:rPr lang="ru-RU" smtClean="0"/>
-              <a:t>22.04.2026</a:t>
+              <a:t>29.04.2026</a:t>
             </a:fld>
             <a:endParaRPr lang="ru-RU"/>
           </a:p>
@@ -1314,7 +1314,7 @@
           <a:p>
             <a:fld id="{63954F16-EF89-444B-B5EE-096ABF5F48C7}" type="datetime1">
               <a:rPr lang="ru-RU" smtClean="0"/>
-              <a:t>22.04.2026</a:t>
+              <a:t>29.04.2026</a:t>
             </a:fld>
             <a:endParaRPr lang="ru-RU"/>
           </a:p>
@@ -1589,7 +1589,7 @@
           <a:p>
             <a:fld id="{26E6D5F6-1A3B-4480-A930-7B5D513F4301}" type="datetime1">
               <a:rPr lang="ru-RU" smtClean="0"/>
-              <a:t>22.04.2026</a:t>
+              <a:t>29.04.2026</a:t>
             </a:fld>
             <a:endParaRPr lang="ru-RU"/>
           </a:p>
@@ -1854,7 +1854,7 @@
           <a:p>
             <a:fld id="{C0461997-42E7-4A3D-AFD9-A4B06E9A2CD4}" type="datetime1">
               <a:rPr lang="ru-RU" smtClean="0"/>
-              <a:t>22.04.2026</a:t>
+              <a:t>29.04.2026</a:t>
             </a:fld>
             <a:endParaRPr lang="ru-RU"/>
           </a:p>
@@ -2266,7 +2266,7 @@
           <a:p>
             <a:fld id="{00D1E04C-46DC-49F7-BB58-C0F68A028918}" type="datetime1">
               <a:rPr lang="ru-RU" smtClean="0"/>
-              <a:t>22.04.2026</a:t>
+              <a:t>29.04.2026</a:t>
             </a:fld>
             <a:endParaRPr lang="ru-RU"/>
           </a:p>
@@ -2407,7 +2407,7 @@
           <a:p>
             <a:fld id="{42BDAAF7-7DCA-4B59-8EFF-412AF87020B2}" type="datetime1">
               <a:rPr lang="ru-RU" smtClean="0"/>
-              <a:t>22.04.2026</a:t>
+              <a:t>29.04.2026</a:t>
             </a:fld>
             <a:endParaRPr lang="ru-RU"/>
           </a:p>
@@ -2520,7 +2520,7 @@
           <a:p>
             <a:fld id="{09C9192A-75AA-4314-85F0-C37E684E0F1B}" type="datetime1">
               <a:rPr lang="ru-RU" smtClean="0"/>
-              <a:t>22.04.2026</a:t>
+              <a:t>29.04.2026</a:t>
             </a:fld>
             <a:endParaRPr lang="ru-RU"/>
           </a:p>
@@ -2831,7 +2831,7 @@
           <a:p>
             <a:fld id="{1EA6CD73-1DC1-4CCB-8639-48CA902A4BE7}" type="datetime1">
               <a:rPr lang="ru-RU" smtClean="0"/>
-              <a:t>22.04.2026</a:t>
+              <a:t>29.04.2026</a:t>
             </a:fld>
             <a:endParaRPr lang="ru-RU"/>
           </a:p>
@@ -3119,7 +3119,7 @@
           <a:p>
             <a:fld id="{25FEEA16-318D-49A8-B19A-6FCF07807A8C}" type="datetime1">
               <a:rPr lang="ru-RU" smtClean="0"/>
-              <a:t>22.04.2026</a:t>
+              <a:t>29.04.2026</a:t>
             </a:fld>
             <a:endParaRPr lang="ru-RU"/>
           </a:p>
@@ -3360,7 +3360,7 @@
           <a:p>
             <a:fld id="{29DA6B07-345E-41F3-AB13-E427DFAF8E87}" type="datetime1">
               <a:rPr lang="ru-RU" smtClean="0"/>
-              <a:t>22.04.2026</a:t>
+              <a:t>29.04.2026</a:t>
             </a:fld>
             <a:endParaRPr lang="ru-RU"/>
           </a:p>
@@ -3922,7 +3922,7 @@
         <p:spPr>
           <a:xfrm>
             <a:off x="1413130" y="325135"/>
-            <a:ext cx="10023895" cy="1323439"/>
+            <a:ext cx="10023895" cy="1077218"/>
           </a:xfrm>
           <a:prstGeom prst="rect">
             <a:avLst/>
@@ -3934,23 +3934,6 @@
             <a:spAutoFit/>
           </a:bodyPr>
           <a:lstStyle/>
-          <a:p>
-            <a:pPr algn="ctr"/>
-            <a:r>
-              <a:rPr lang="ru-RU" sz="1600" b="1" dirty="0">
-                <a:effectLst/>
-                <a:latin typeface="Times New Roman" panose="02020603050405020304" pitchFamily="18" charset="0"/>
-                <a:ea typeface="Times New Roman" panose="02020603050405020304" pitchFamily="18" charset="0"/>
-                <a:cs typeface="Liberation Serif"/>
-              </a:rPr>
-              <a:t>Министерство науки и высшего образования Российской Федерации</a:t>
-            </a:r>
-            <a:endParaRPr lang="ru-RU" sz="1600" dirty="0">
-              <a:effectLst/>
-              <a:latin typeface="Times New Roman" panose="02020603050405020304" pitchFamily="18" charset="0"/>
-              <a:ea typeface="Times New Roman" panose="02020603050405020304" pitchFamily="18" charset="0"/>
-            </a:endParaRPr>
-          </a:p>
           <a:p>
             <a:pPr algn="ctr"/>
             <a:r>
@@ -6589,13 +6572,13 @@
         </p:nvSpPr>
         <p:spPr>
           <a:xfrm>
-            <a:off x="838200" y="1825625"/>
-            <a:ext cx="10850592" cy="4351338"/>
+            <a:off x="534429" y="1817387"/>
+            <a:ext cx="11385722" cy="4351338"/>
           </a:xfrm>
         </p:spPr>
         <p:txBody>
           <a:bodyPr>
-            <a:normAutofit fontScale="92500"/>
+            <a:normAutofit/>
           </a:bodyPr>
           <a:lstStyle/>
           <a:p>
@@ -6642,32 +6625,53 @@
               <a:buChar char="-"/>
             </a:pPr>
             <a:r>
-              <a:rPr lang="ru-RU" dirty="0">
+              <a:rPr lang="ru-RU" sz="2400" dirty="0">
                 <a:latin typeface="Times New Roman" panose="02020603050405020304" pitchFamily="18" charset="0"/>
                 <a:cs typeface="Times New Roman" panose="02020603050405020304" pitchFamily="18" charset="0"/>
               </a:rPr>
-              <a:t>п</a:t>
-            </a:r>
-            <a:r>
-              <a:rPr lang="ru-RU" sz="2800" dirty="0">
+              <a:t>провести сравнительный анализ методов</a:t>
+            </a:r>
+            <a:r>
+              <a:rPr lang="en-US" sz="2400" dirty="0">
                 <a:latin typeface="Times New Roman" panose="02020603050405020304" pitchFamily="18" charset="0"/>
                 <a:cs typeface="Times New Roman" panose="02020603050405020304" pitchFamily="18" charset="0"/>
               </a:rPr>
-              <a:t>ровести анализ предметной области и сравнительный анализ существующих</a:t>
-            </a:r>
-            <a:r>
-              <a:rPr lang="vi-VN" sz="2800" dirty="0">
+              <a:t> </a:t>
+            </a:r>
+            <a:r>
+              <a:rPr lang="ru-RU" sz="2400" dirty="0">
                 <a:latin typeface="Times New Roman" panose="02020603050405020304" pitchFamily="18" charset="0"/>
                 <a:cs typeface="Times New Roman" panose="02020603050405020304" pitchFamily="18" charset="0"/>
               </a:rPr>
-              <a:t> </a:t>
-            </a:r>
-            <a:r>
-              <a:rPr lang="ru-RU" sz="2800" dirty="0">
+              <a:t>обнаружения</a:t>
+            </a:r>
+            <a:r>
+              <a:rPr lang="en-US" sz="2400" dirty="0">
                 <a:latin typeface="Times New Roman" panose="02020603050405020304" pitchFamily="18" charset="0"/>
                 <a:cs typeface="Times New Roman" panose="02020603050405020304" pitchFamily="18" charset="0"/>
               </a:rPr>
-              <a:t>методов;</a:t>
+              <a:t> </a:t>
+            </a:r>
+            <a:r>
+              <a:rPr lang="ru-RU" sz="2400" dirty="0">
+                <a:latin typeface="Times New Roman" panose="02020603050405020304" pitchFamily="18" charset="0"/>
+                <a:cs typeface="Times New Roman" panose="02020603050405020304" pitchFamily="18" charset="0"/>
+              </a:rPr>
+              <a:t>фальсифицированного</a:t>
+            </a:r>
+            <a:r>
+              <a:rPr lang="en-US" sz="2400" dirty="0">
+                <a:latin typeface="Times New Roman" panose="02020603050405020304" pitchFamily="18" charset="0"/>
+                <a:cs typeface="Times New Roman" panose="02020603050405020304" pitchFamily="18" charset="0"/>
+              </a:rPr>
+              <a:t> </a:t>
+            </a:r>
+            <a:r>
+              <a:rPr lang="ru-RU" sz="2400" dirty="0">
+                <a:latin typeface="Times New Roman" panose="02020603050405020304" pitchFamily="18" charset="0"/>
+                <a:cs typeface="Times New Roman" panose="02020603050405020304" pitchFamily="18" charset="0"/>
+              </a:rPr>
+              <a:t>фрагмента на изображении ;</a:t>
             </a:r>
           </a:p>
           <a:p>
@@ -6676,18 +6680,11 @@
               <a:buChar char="-"/>
             </a:pPr>
             <a:r>
-              <a:rPr lang="ru-RU" dirty="0">
+              <a:rPr lang="ru-RU" sz="2400" dirty="0">
                 <a:latin typeface="Times New Roman" panose="02020603050405020304" pitchFamily="18" charset="0"/>
                 <a:cs typeface="Times New Roman" panose="02020603050405020304" pitchFamily="18" charset="0"/>
               </a:rPr>
-              <a:t>спроектировать метод обнаружения фальсифицированного фрагмента на изображении с использованием сверточной нейронной сети</a:t>
-            </a:r>
-            <a:r>
-              <a:rPr lang="ru-RU" sz="2800" dirty="0">
-                <a:latin typeface="Times New Roman" panose="02020603050405020304" pitchFamily="18" charset="0"/>
-                <a:cs typeface="Times New Roman" panose="02020603050405020304" pitchFamily="18" charset="0"/>
-              </a:rPr>
-              <a:t>;</a:t>
+              <a:t>разработать метод обнаружения фальсифицированного фрагмента на изображении с использованием сверточной нейронной сети;</a:t>
             </a:r>
           </a:p>
           <a:p>
@@ -6696,7 +6693,7 @@
               <a:buChar char="-"/>
             </a:pPr>
             <a:r>
-              <a:rPr lang="ru-RU" dirty="0">
+              <a:rPr lang="ru-RU" sz="2400" dirty="0">
                 <a:latin typeface="Times New Roman" panose="02020603050405020304" pitchFamily="18" charset="0"/>
                 <a:cs typeface="Times New Roman" panose="02020603050405020304" pitchFamily="18" charset="0"/>
               </a:rPr>
@@ -6709,16 +6706,12 @@
               <a:buChar char="-"/>
             </a:pPr>
             <a:r>
-              <a:rPr lang="ru-RU" dirty="0">
+              <a:rPr lang="ru-RU" sz="2400" dirty="0">
                 <a:latin typeface="Times New Roman" panose="02020603050405020304" pitchFamily="18" charset="0"/>
                 <a:cs typeface="Times New Roman" panose="02020603050405020304" pitchFamily="18" charset="0"/>
               </a:rPr>
-              <a:t>провести оценку качества реализованный метода.</a:t>
-            </a:r>
-            <a:endParaRPr lang="ru-RU" sz="2800" dirty="0">
-              <a:latin typeface="Times New Roman" panose="02020603050405020304" pitchFamily="18" charset="0"/>
-              <a:cs typeface="Times New Roman" panose="02020603050405020304" pitchFamily="18" charset="0"/>
-            </a:endParaRPr>
+              <a:t>провести исследование эффективности реализованного метода.</a:t>
+            </a:r>
           </a:p>
           <a:p>
             <a:pPr marL="0" indent="0">
@@ -8728,41 +8721,6 @@
           </a:p>
         </p:txBody>
       </p:sp>
-      <p:pic>
-        <p:nvPicPr>
-          <p:cNvPr id="14" name="Content Placeholder 13">
-            <a:extLst>
-              <a:ext uri="{FF2B5EF4-FFF2-40B4-BE49-F238E27FC236}">
-                <a16:creationId xmlns:a16="http://schemas.microsoft.com/office/drawing/2014/main" id="{0B5EB20E-B802-DC20-84FD-1BD25EAFA4EF}"/>
-              </a:ext>
-            </a:extLst>
-          </p:cNvPr>
-          <p:cNvPicPr>
-            <a:picLocks noGrp="1" noChangeAspect="1"/>
-          </p:cNvPicPr>
-          <p:nvPr>
-            <p:ph idx="1"/>
-          </p:nvPr>
-        </p:nvPicPr>
-        <p:blipFill>
-          <a:blip r:embed="rId2">
-            <a:extLst>
-              <a:ext uri="{28A0092B-C50C-407E-A947-70E740481C1C}">
-                <a14:useLocalDpi xmlns:a14="http://schemas.microsoft.com/office/drawing/2010/main" val="0"/>
-              </a:ext>
-            </a:extLst>
-          </a:blip>
-          <a:stretch>
-            <a:fillRect/>
-          </a:stretch>
-        </p:blipFill>
-        <p:spPr>
-          <a:xfrm>
-            <a:off x="7343505" y="1084859"/>
-            <a:ext cx="1586310" cy="5471969"/>
-          </a:xfrm>
-        </p:spPr>
-      </p:pic>
       <p:sp>
         <p:nvSpPr>
           <p:cNvPr id="16" name="TextBox 15">
@@ -8835,6 +8793,41 @@
           </a:p>
         </p:txBody>
       </p:sp>
+      <p:pic>
+        <p:nvPicPr>
+          <p:cNvPr id="7" name="Content Placeholder 6">
+            <a:extLst>
+              <a:ext uri="{FF2B5EF4-FFF2-40B4-BE49-F238E27FC236}">
+                <a16:creationId xmlns:a16="http://schemas.microsoft.com/office/drawing/2014/main" id="{24E75607-6ACE-BA33-965E-7172469A03C8}"/>
+              </a:ext>
+            </a:extLst>
+          </p:cNvPr>
+          <p:cNvPicPr>
+            <a:picLocks noGrp="1" noChangeAspect="1"/>
+          </p:cNvPicPr>
+          <p:nvPr>
+            <p:ph idx="1"/>
+          </p:nvPr>
+        </p:nvPicPr>
+        <p:blipFill>
+          <a:blip r:embed="rId2">
+            <a:extLst>
+              <a:ext uri="{28A0092B-C50C-407E-A947-70E740481C1C}">
+                <a14:useLocalDpi xmlns:a14="http://schemas.microsoft.com/office/drawing/2010/main" val="0"/>
+              </a:ext>
+            </a:extLst>
+          </a:blip>
+          <a:stretch>
+            <a:fillRect/>
+          </a:stretch>
+        </p:blipFill>
+        <p:spPr>
+          <a:xfrm>
+            <a:off x="8224071" y="856145"/>
+            <a:ext cx="1758129" cy="5500205"/>
+          </a:xfrm>
+        </p:spPr>
+      </p:pic>
     </p:spTree>
     <p:extLst>
       <p:ext uri="{BB962C8B-B14F-4D97-AF65-F5344CB8AC3E}">

</xml_diff>